<commit_message>
Module 8: close the session-plan gaps
Adds mark-to-market and IFRS 9 to the NAV steps, AML to the KYC card, and
investor reporting to the NAV slide. The lab script now writes an optional
formatted nav_report.xlsx (portfolio after reconciliation, NAV before and
after, sign-off line, breaks sheet) where openpyxl is available, as in Colab,
and skips it cleanly elsewhere.

Co-Authored-By: Claude Opus 5.5 <noreply@anthropic.com>
</commit_message>
<xml_diff>
--- a/slides/Module-08-Fund-Administration-NAV.pptx
+++ b/slides/Module-08-Fund-Administration-NAV.pptx
@@ -6710,7 +6710,7 @@
                   <a:srgbClr val="1B2A41"/>
                 </a:solidFill>
               </a:rPr>
-              <a:t>Run nav_engine.py in Codex, Colab or any Python. It prices the fund, finds the breaks and writes nav_report.csv.</a:t>
+              <a:t>Run nav_engine.py in Codex, Colab or any Python. It prices the fund, finds the breaks and writes the NAV report. In Colab it also writes a formatted Excel report.</a:t>
             </a:r>
           </a:p>
         </p:txBody>
@@ -13350,7 +13350,7 @@
                   <a:srgbClr val="1B2A41"/>
                 </a:solidFill>
               </a:rPr>
-              <a:t>Price every holding at today's closing price.</a:t>
+              <a:t>Price every holding at today's close. This is mark-to-market, or fair value under IFRS 9.</a:t>
             </a:r>
           </a:p>
         </p:txBody>
@@ -14248,7 +14248,7 @@
                   <a:srgbClr val="FFFFFF"/>
                 </a:solidFill>
               </a:rPr>
-              <a:t>NAV = (holdings at market price + cash − expenses) ÷ units. Indian mutual funds publish it on the AMFI website every day.</a:t>
+              <a:t>NAV = (holdings at market price + cash − expenses) ÷ units. Investors then get the daily NAV on AMFI, a statement from the RTA and the portfolio every month.</a:t>
             </a:r>
           </a:p>
         </p:txBody>
@@ -14577,7 +14577,7 @@
                   <a:srgbClr val="3A5C9E"/>
                 </a:solidFill>
               </a:rPr>
-              <a:t>STEP 1 · KYC</a:t>
+              <a:t>STEP 1 · KYC AND AML</a:t>
             </a:r>
           </a:p>
           <a:p>
@@ -14608,7 +14608,7 @@
                   <a:srgbClr val="1B2A41"/>
                 </a:solidFill>
               </a:rPr>
-              <a:t>The investor gives PAN and Aadhaar. Under SEBI rules KYC is done once and stored with a KYC registration agency.</a:t>
+              <a:t>The investor gives PAN and Aadhaar. AML checks screen out money laundering. KYC is done once and stored with a KYC registration agency.</a:t>
             </a:r>
           </a:p>
         </p:txBody>

</xml_diff>

<commit_message>
Module 8: say the administrator records the manager's trades, not books them
Co-Authored-By: Claude Opus 5.5 <noreply@anthropic.com>
</commit_message>
<xml_diff>
--- a/slides/Module-08-Fund-Administration-NAV.pptx
+++ b/slides/Module-08-Fund-Administration-NAV.pptx
@@ -11274,7 +11274,7 @@
                   <a:srgbClr val="FFFFFF"/>
                 </a:solidFill>
               </a:rPr>
-              <a:t>Price holdings, book trades and corporate actions, reconcile, calculate NAV</a:t>
+              <a:t>Record the manager's trades in the books, price holdings, process corporate actions, reconcile, calculate NAV</a:t>
             </a:r>
           </a:p>
         </p:txBody>
@@ -13281,7 +13281,7 @@
                   <a:srgbClr val="1B2A41"/>
                 </a:solidFill>
               </a:rPr>
-              <a:t>Capture every trade done today.</a:t>
+              <a:t>Record every trade the fund manager made today.</a:t>
             </a:r>
           </a:p>
         </p:txBody>

</xml_diff>